<commit_message>
docs: tighten deck findings, incident wording and testnet evidence
PMF states the Protocol 23 incident as published: 478 contract entries
archived with stale values, 84 restored into live state before
Protocol 24. ARCHITECTURE uses the same framing. Findings lists the
keep-alive and restoration-cost results as separate findings. The
Testnet slide shows only the stellar.expert summary and transfer call,
re-rendered at twice the resolution and enlarged to the full picture
height. The team slide's next steps follow the roadmap.
</commit_message>
<xml_diff>
--- a/docs/deck/breakwater-pitch.pptx
+++ b/docs/deck/breakwater-pitch.pptx
@@ -12968,7 +12968,7 @@
                 <a:cs typeface="Instrument Sans"/>
                 <a:sym typeface="Instrument Sans"/>
               </a:rPr>
-              <a:t>State archival: after mainnet moved to Protocol 23, archived entries were restored with stale values (478 entries affected).</a:t>
+              <a:t>Protocol 23 archived 478 contract entries with stale values; 84 were restored into live state before Protocol 24 fixed it.</a:t>
             </a:r>
             <a:endParaRPr/>
           </a:p>
@@ -14745,7 +14745,7 @@
                 <a:cs typeface="Instrument Sans"/>
                 <a:sym typeface="Instrument Sans"/>
               </a:rPr>
-              <a:t>Next: rule-rotation probe, malicious keep-alive, restoration-cost CI gate.</a:t>
+              <a:t>Next: rule-rotation probe, restoration-cost CI gate, XDR replay export; then crates.io and a GitHub Action.</a:t>
             </a:r>
             <a:endParaRPr/>
           </a:p>
@@ -15418,7 +15418,7 @@
         <p:spPr>
           <a:xfrm>
             <a:off x="914400" y="4800600"/>
-            <a:ext cx="7863840" cy="2286000"/>
+            <a:ext cx="7863840" cy="2697480"/>
           </a:xfrm>
           <a:prstGeom prst="rect">
             <a:avLst/>
@@ -15458,7 +15458,7 @@
                 <a:cs typeface="Instrument Sans"/>
                 <a:sym typeface="Instrument Sans"/>
               </a:rPr>
-              <a:t>Daily cap set to 1 728 ledgers, not 17 280: 49 → 49 → 49 USDC (+1 / +10 / +1718 ledgers) is 147 in 24 h against a 100 cap; up to 10× per day.</a:t>
+              <a:t>Daily window 1 728 ledgers, not 17 280: 49 → 49 → 49 USDC (+1 / +10 / +1718) is 147 in 24 h vs a 100 cap; up to 10× a day.</a:t>
             </a:r>
             <a:endParaRPr/>
           </a:p>
@@ -15487,7 +15487,7 @@
                 <a:cs typeface="Instrument Sans"/>
                 <a:sym typeface="Instrument Sans"/>
               </a:rPr>
-              <a:t>Stream that never extends TTL: “stream 0 is archived with 275 days left to run”.</a:t>
+              <a:t>No extend_ttl: “stream 0 is archived with 275 days left to run”.</a:t>
             </a:r>
             <a:endParaRPr/>
           </a:p>
@@ -15516,7 +15516,36 @@
                 <a:cs typeface="Instrument Sans"/>
                 <a:sym typeface="Instrument Sans"/>
               </a:rPr>
-              <a:t>Unauthenticated bump_ttl keeps an entry alive 1.3 days past its stream; one call restores 5 entries against a budget of 3.</a:t>
+              <a:t>Unauthenticated bump_ttl keeps a stream alive 1.3 days past its end.</a:t>
+            </a:r>
+            <a:endParaRPr/>
+          </a:p>
+          <a:p>
+            <a:pPr indent="-411480" lvl="0" marL="411480" marR="0" rtl="0" algn="l">
+              <a:spcBef>
+                <a:spcPts val="0"/>
+              </a:spcBef>
+              <a:spcAft>
+                <a:spcPts val="0"/>
+              </a:spcAft>
+              <a:buClr>
+                <a:srgbClr val="0F0F0F"/>
+              </a:buClr>
+              <a:buSzPts val="2400"/>
+              <a:buFont typeface="Arial"/>
+              <a:buChar char="►"/>
+            </a:pPr>
+            <a:r>
+              <a:rPr b="0" i="0" lang="en-US" sz="2000" u="none" cap="none" strike="noStrike">
+                <a:solidFill>
+                  <a:srgbClr val="2A2A2A"/>
+                </a:solidFill>
+                <a:latin typeface="Instrument Sans"/>
+                <a:ea typeface="Instrument Sans"/>
+                <a:cs typeface="Instrument Sans"/>
+                <a:sym typeface="Instrument Sans"/>
+              </a:rPr>
+              <a:t>After 90 quiet days one withdraw_many restores 5 entries against a budget of 3.</a:t>
             </a:r>
             <a:endParaRPr/>
           </a:p>
@@ -15530,7 +15559,7 @@
         </p:nvSpPr>
         <p:spPr>
           <a:xfrm>
-            <a:off x="914400" y="7269480"/>
+            <a:off x="914400" y="7635240"/>
             <a:ext cx="7863840" cy="914400"/>
           </a:xfrm>
           <a:prstGeom prst="roundRect">
@@ -16467,37 +16496,8 @@
         </p:blipFill>
         <p:spPr>
           <a:xfrm>
-            <a:off x="9326880" y="4185984"/>
-            <a:ext cx="8046720" cy="2126633"/>
-          </a:xfrm>
-          <a:prstGeom prst="rect">
-            <a:avLst/>
-          </a:prstGeom>
-          <a:ln w="12700">
-            <a:solidFill>
-              <a:srgbClr val="DFDDD6"/>
-            </a:solidFill>
-          </a:ln>
-        </p:spPr>
-      </p:pic>
-      <p:pic xmlns:p="http://schemas.openxmlformats.org/presentationml/2006/main" xmlns:a="http://schemas.openxmlformats.org/drawingml/2006/main" xmlns:r="http://schemas.openxmlformats.org/officeDocument/2006/relationships">
-        <p:nvPicPr>
-          <p:cNvPr id="169" name="Screenshot S6-github-merged-prs.png" descr="S6-github-merged-prs.png"/>
-          <p:cNvPicPr>
-            <a:picLocks noChangeAspect="1"/>
-          </p:cNvPicPr>
-          <p:nvPr/>
-        </p:nvPicPr>
-        <p:blipFill>
-          <a:blip r:embed="rId202"/>
-          <a:stretch>
-            <a:fillRect/>
-          </a:stretch>
-        </p:blipFill>
-        <p:spPr>
-          <a:xfrm>
-            <a:off x="9326880" y="6495497"/>
-            <a:ext cx="8046720" cy="1708638"/>
+            <a:off x="10056730" y="3794760"/>
+            <a:ext cx="6587021" cy="4800600"/>
           </a:xfrm>
           <a:prstGeom prst="rect">
             <a:avLst/>

</xml_diff>

<commit_message>
docs: polish the readme, architecture diagrams and pitch deck
Uses the transparent logo in the README and on the deck cover, groups
the README badges into three rows (project, stack, hackathon), and
replaces the box-drawing diagrams in the README and ARCHITECTURE with
Mermaid. On the deck, the template's "Think" callouts get a short label
per slide, and the commit, pull request and test counts are synced to
the state after this change (19, 18, 43).
</commit_message>
<xml_diff>
--- a/docs/deck/breakwater-pitch.pptx
+++ b/docs/deck/breakwater-pitch.pptx
@@ -11774,6 +11774,34 @@
           </a:p>
         </p:txBody>
       </p:sp>
+      <p:pic>
+        <p:nvPicPr>
+          <p:cNvPr descr="Breakwater logo: a wave breaking on a tetrapod" id="200" name="Breakwater logo"/>
+          <p:cNvPicPr>
+            <a:picLocks noChangeAspect="1"/>
+          </p:cNvPicPr>
+          <p:nvPr/>
+        </p:nvPicPr>
+        <p:blipFill>
+          <a:blip r:embed="rId6"/>
+          <a:stretch>
+            <a:fillRect/>
+          </a:stretch>
+        </p:blipFill>
+        <p:spPr>
+          <a:xfrm>
+            <a:off x="7143750" y="2628900"/>
+            <a:ext cx="4572000" cy="3124200"/>
+          </a:xfrm>
+          <a:prstGeom prst="rect">
+            <a:avLst/>
+          </a:prstGeom>
+          <a:noFill/>
+          <a:ln>
+            <a:noFill/>
+          </a:ln>
+        </p:spPr>
+      </p:pic>
     </p:spTree>
   </p:cSld>
   <p:clrMapOvr>
@@ -12328,7 +12356,7 @@
                 <a:cs typeface="Instrument Sans"/>
                 <a:sym typeface="Instrument Sans"/>
               </a:rPr>
-              <a:t>👉 Think: </a:t>
+              <a:t>Why sequences: </a:t>
             </a:r>
             <a:r>
               <a:rPr b="0" i="0" lang="en-US" sz="2000" u="none" cap="none" strike="noStrike">
@@ -13057,7 +13085,7 @@
                 <a:cs typeface="Instrument Sans"/>
                 <a:sym typeface="Instrument Sans"/>
               </a:rPr>
-              <a:t>👉 Think: </a:t>
+              <a:t>The gap: </a:t>
             </a:r>
             <a:r>
               <a:rPr b="0" i="0" lang="en-US" sz="2000" u="none" cap="none" strike="noStrike">
@@ -13786,7 +13814,7 @@
                 <a:cs typeface="Instrument Sans"/>
                 <a:sym typeface="Instrument Sans"/>
               </a:rPr>
-              <a:t>👉 Think: </a:t>
+              <a:t>Real auth: </a:t>
             </a:r>
             <a:r>
               <a:rPr b="0" i="0" lang="en-US" sz="2000" u="none" cap="none" strike="noStrike">
@@ -14805,7 +14833,7 @@
                 <a:cs typeface="Instrument Sans"/>
                 <a:sym typeface="Instrument Sans"/>
               </a:rPr>
-              <a:t>👉 Think: </a:t>
+              <a:t>Provenance: </a:t>
             </a:r>
             <a:r>
               <a:rPr b="0" i="0" lang="en-US" sz="2000" u="none" cap="none" strike="noStrike">
@@ -15605,7 +15633,7 @@
                 <a:cs typeface="Instrument Sans"/>
                 <a:sym typeface="Instrument Sans"/>
               </a:rPr>
-              <a:t>👉 Think: </a:t>
+              <a:t>Takeaway: </a:t>
             </a:r>
             <a:r>
               <a:rPr b="0" i="0" lang="en-US" sz="2000" u="none" cap="none" strike="noStrike">
@@ -16274,7 +16302,7 @@
                 <a:cs typeface="Instrument Sans"/>
                 <a:sym typeface="Instrument Sans"/>
               </a:rPr>
-              <a:t>Built during the event: 11 commits on main, 10 merged PRs, 40 tests, CI on every PR.</a:t>
+              <a:t>Built during the event: 19 commits on main, 18 merged PRs, 43 tests, CI on every PR.</a:t>
             </a:r>
             <a:endParaRPr/>
           </a:p>
@@ -16334,7 +16362,7 @@
                 <a:cs typeface="Instrument Sans"/>
                 <a:sym typeface="Instrument Sans"/>
               </a:rPr>
-              <a:t>👉 Think: </a:t>
+              <a:t>Reproducible: </a:t>
             </a:r>
             <a:r>
               <a:rPr b="0" i="0" lang="en-US" sz="2000" u="none" cap="none" strike="noStrike">

</xml_diff>

<commit_message>
docs: polish the readme, architecture diagrams and pitch deck (#18)
Uses the transparent logo in the README and on the deck cover, groups
the README badges into three rows (project, stack, hackathon), and
replaces the box-drawing diagrams in the README and ARCHITECTURE with
Mermaid. On the deck, the template's "Think" callouts get a short label
per slide, and the commit, pull request and test counts are synced to
the state after this change (19, 18, 43).
</commit_message>
<xml_diff>
--- a/docs/deck/breakwater-pitch.pptx
+++ b/docs/deck/breakwater-pitch.pptx
@@ -11774,6 +11774,34 @@
           </a:p>
         </p:txBody>
       </p:sp>
+      <p:pic>
+        <p:nvPicPr>
+          <p:cNvPr descr="Breakwater logo: a wave breaking on a tetrapod" id="200" name="Breakwater logo"/>
+          <p:cNvPicPr>
+            <a:picLocks noChangeAspect="1"/>
+          </p:cNvPicPr>
+          <p:nvPr/>
+        </p:nvPicPr>
+        <p:blipFill>
+          <a:blip r:embed="rId6"/>
+          <a:stretch>
+            <a:fillRect/>
+          </a:stretch>
+        </p:blipFill>
+        <p:spPr>
+          <a:xfrm>
+            <a:off x="7143750" y="2628900"/>
+            <a:ext cx="4572000" cy="3124200"/>
+          </a:xfrm>
+          <a:prstGeom prst="rect">
+            <a:avLst/>
+          </a:prstGeom>
+          <a:noFill/>
+          <a:ln>
+            <a:noFill/>
+          </a:ln>
+        </p:spPr>
+      </p:pic>
     </p:spTree>
   </p:cSld>
   <p:clrMapOvr>
@@ -12328,7 +12356,7 @@
                 <a:cs typeface="Instrument Sans"/>
                 <a:sym typeface="Instrument Sans"/>
               </a:rPr>
-              <a:t>👉 Think: </a:t>
+              <a:t>Why sequences: </a:t>
             </a:r>
             <a:r>
               <a:rPr b="0" i="0" lang="en-US" sz="2000" u="none" cap="none" strike="noStrike">
@@ -13057,7 +13085,7 @@
                 <a:cs typeface="Instrument Sans"/>
                 <a:sym typeface="Instrument Sans"/>
               </a:rPr>
-              <a:t>👉 Think: </a:t>
+              <a:t>The gap: </a:t>
             </a:r>
             <a:r>
               <a:rPr b="0" i="0" lang="en-US" sz="2000" u="none" cap="none" strike="noStrike">
@@ -13786,7 +13814,7 @@
                 <a:cs typeface="Instrument Sans"/>
                 <a:sym typeface="Instrument Sans"/>
               </a:rPr>
-              <a:t>👉 Think: </a:t>
+              <a:t>Real auth: </a:t>
             </a:r>
             <a:r>
               <a:rPr b="0" i="0" lang="en-US" sz="2000" u="none" cap="none" strike="noStrike">
@@ -14805,7 +14833,7 @@
                 <a:cs typeface="Instrument Sans"/>
                 <a:sym typeface="Instrument Sans"/>
               </a:rPr>
-              <a:t>👉 Think: </a:t>
+              <a:t>Provenance: </a:t>
             </a:r>
             <a:r>
               <a:rPr b="0" i="0" lang="en-US" sz="2000" u="none" cap="none" strike="noStrike">
@@ -15605,7 +15633,7 @@
                 <a:cs typeface="Instrument Sans"/>
                 <a:sym typeface="Instrument Sans"/>
               </a:rPr>
-              <a:t>👉 Think: </a:t>
+              <a:t>Takeaway: </a:t>
             </a:r>
             <a:r>
               <a:rPr b="0" i="0" lang="en-US" sz="2000" u="none" cap="none" strike="noStrike">
@@ -16274,7 +16302,7 @@
                 <a:cs typeface="Instrument Sans"/>
                 <a:sym typeface="Instrument Sans"/>
               </a:rPr>
-              <a:t>Built during the event: 11 commits on main, 10 merged PRs, 40 tests, CI on every PR.</a:t>
+              <a:t>Built during the event: 19 commits on main, 18 merged PRs, 43 tests, CI on every PR.</a:t>
             </a:r>
             <a:endParaRPr/>
           </a:p>
@@ -16334,7 +16362,7 @@
                 <a:cs typeface="Instrument Sans"/>
                 <a:sym typeface="Instrument Sans"/>
               </a:rPr>
-              <a:t>👉 Think: </a:t>
+              <a:t>Reproducible: </a:t>
             </a:r>
             <a:r>
               <a:rPr b="0" i="0" lang="en-US" sz="2000" u="none" cap="none" strike="noStrike">

</xml_diff>